<commit_message>
Added value additions and combined Cloud consulting and Finops into one category
</commit_message>
<xml_diff>
--- a/marketing-strategy.pptx
+++ b/marketing-strategy.pptx
@@ -13,7 +13,8 @@
     <p:sldId id="261" r:id="rId7"/>
     <p:sldId id="262" r:id="rId8"/>
     <p:sldId id="263" r:id="rId9"/>
-    <p:sldId id="264" r:id="rId10"/>
+    <p:sldId id="265" r:id="rId10"/>
+    <p:sldId id="264" r:id="rId11"/>
   </p:sldIdLst>
   <p:sldSz cx="9144000" cy="6858000" type="screen4x3"/>
   <p:notesSz cx="6858000" cy="9144000"/>
@@ -143,11 +144,26 @@
 <pc:chgInfo xmlns:a="http://schemas.openxmlformats.org/drawingml/2006/main" xmlns:r="http://schemas.openxmlformats.org/officeDocument/2006/relationships" xmlns:ac="http://schemas.microsoft.com/office/drawing/2013/main/command" xmlns:pc="http://schemas.microsoft.com/office/powerpoint/2013/main/command">
   <pc:docChgLst>
     <pc:chgData name="Rajendran Rathinasabapathy" userId="8f079d080975a996" providerId="LiveId" clId="{16F65AB7-6BAD-45A1-993A-C8D9CCEBF953}"/>
-    <pc:docChg chg="modSld">
-      <pc:chgData name="Rajendran Rathinasabapathy" userId="8f079d080975a996" providerId="LiveId" clId="{16F65AB7-6BAD-45A1-993A-C8D9CCEBF953}" dt="2026-03-29T17:36:48.188" v="16" actId="20577"/>
+    <pc:docChg chg="custSel modSld sldOrd">
+      <pc:chgData name="Rajendran Rathinasabapathy" userId="8f079d080975a996" providerId="LiveId" clId="{16F65AB7-6BAD-45A1-993A-C8D9CCEBF953}" dt="2026-04-04T17:00:49.600" v="35"/>
       <pc:docMkLst>
         <pc:docMk/>
       </pc:docMkLst>
+      <pc:sldChg chg="modSp mod">
+        <pc:chgData name="Rajendran Rathinasabapathy" userId="8f079d080975a996" providerId="LiveId" clId="{16F65AB7-6BAD-45A1-993A-C8D9CCEBF953}" dt="2026-04-04T16:58:54.557" v="33" actId="20577"/>
+        <pc:sldMkLst>
+          <pc:docMk/>
+          <pc:sldMk cId="0" sldId="259"/>
+        </pc:sldMkLst>
+        <pc:spChg chg="mod">
+          <ac:chgData name="Rajendran Rathinasabapathy" userId="8f079d080975a996" providerId="LiveId" clId="{16F65AB7-6BAD-45A1-993A-C8D9CCEBF953}" dt="2026-04-04T16:58:54.557" v="33" actId="20577"/>
+          <ac:spMkLst>
+            <pc:docMk/>
+            <pc:sldMk cId="0" sldId="259"/>
+            <ac:spMk id="3" creationId="{00000000-0000-0000-0000-000000000000}"/>
+          </ac:spMkLst>
+        </pc:spChg>
+      </pc:sldChg>
       <pc:sldChg chg="modSp mod">
         <pc:chgData name="Rajendran Rathinasabapathy" userId="8f079d080975a996" providerId="LiveId" clId="{16F65AB7-6BAD-45A1-993A-C8D9CCEBF953}" dt="2026-03-29T17:36:48.188" v="16" actId="20577"/>
         <pc:sldMkLst>
@@ -162,6 +178,13 @@
             <ac:spMk id="3" creationId="{00000000-0000-0000-0000-000000000000}"/>
           </ac:spMkLst>
         </pc:spChg>
+      </pc:sldChg>
+      <pc:sldChg chg="ord">
+        <pc:chgData name="Rajendran Rathinasabapathy" userId="8f079d080975a996" providerId="LiveId" clId="{16F65AB7-6BAD-45A1-993A-C8D9CCEBF953}" dt="2026-04-04T17:00:49.600" v="35"/>
+        <pc:sldMkLst>
+          <pc:docMk/>
+          <pc:sldMk cId="0" sldId="265"/>
+        </pc:sldMkLst>
       </pc:sldChg>
     </pc:docChg>
   </pc:docChgLst>
@@ -347,7 +370,7 @@
           <a:p>
             <a:fld id="{5BCAD085-E8A6-8845-BD4E-CB4CCA059FC4}" type="datetimeFigureOut">
               <a:rPr lang="en-US" smtClean="0"/>
-              <a:t>3/29/2026</a:t>
+              <a:t>4/4/2026</a:t>
             </a:fld>
             <a:endParaRPr lang="en-US"/>
           </a:p>
@@ -515,7 +538,7 @@
           <a:p>
             <a:fld id="{5BCAD085-E8A6-8845-BD4E-CB4CCA059FC4}" type="datetimeFigureOut">
               <a:rPr lang="en-US" smtClean="0"/>
-              <a:t>3/29/2026</a:t>
+              <a:t>4/4/2026</a:t>
             </a:fld>
             <a:endParaRPr lang="en-US"/>
           </a:p>
@@ -693,7 +716,7 @@
           <a:p>
             <a:fld id="{5BCAD085-E8A6-8845-BD4E-CB4CCA059FC4}" type="datetimeFigureOut">
               <a:rPr lang="en-US" smtClean="0"/>
-              <a:t>3/29/2026</a:t>
+              <a:t>4/4/2026</a:t>
             </a:fld>
             <a:endParaRPr lang="en-US"/>
           </a:p>
@@ -861,7 +884,7 @@
           <a:p>
             <a:fld id="{5BCAD085-E8A6-8845-BD4E-CB4CCA059FC4}" type="datetimeFigureOut">
               <a:rPr lang="en-US" smtClean="0"/>
-              <a:t>3/29/2026</a:t>
+              <a:t>4/4/2026</a:t>
             </a:fld>
             <a:endParaRPr lang="en-US"/>
           </a:p>
@@ -1106,7 +1129,7 @@
           <a:p>
             <a:fld id="{5BCAD085-E8A6-8845-BD4E-CB4CCA059FC4}" type="datetimeFigureOut">
               <a:rPr lang="en-US" smtClean="0"/>
-              <a:t>3/29/2026</a:t>
+              <a:t>4/4/2026</a:t>
             </a:fld>
             <a:endParaRPr lang="en-US"/>
           </a:p>
@@ -1391,7 +1414,7 @@
           <a:p>
             <a:fld id="{5BCAD085-E8A6-8845-BD4E-CB4CCA059FC4}" type="datetimeFigureOut">
               <a:rPr lang="en-US" smtClean="0"/>
-              <a:t>3/29/2026</a:t>
+              <a:t>4/4/2026</a:t>
             </a:fld>
             <a:endParaRPr lang="en-US"/>
           </a:p>
@@ -1810,7 +1833,7 @@
           <a:p>
             <a:fld id="{5BCAD085-E8A6-8845-BD4E-CB4CCA059FC4}" type="datetimeFigureOut">
               <a:rPr lang="en-US" smtClean="0"/>
-              <a:t>3/29/2026</a:t>
+              <a:t>4/4/2026</a:t>
             </a:fld>
             <a:endParaRPr lang="en-US"/>
           </a:p>
@@ -1927,7 +1950,7 @@
           <a:p>
             <a:fld id="{5BCAD085-E8A6-8845-BD4E-CB4CCA059FC4}" type="datetimeFigureOut">
               <a:rPr lang="en-US" smtClean="0"/>
-              <a:t>3/29/2026</a:t>
+              <a:t>4/4/2026</a:t>
             </a:fld>
             <a:endParaRPr lang="en-US"/>
           </a:p>
@@ -2022,7 +2045,7 @@
           <a:p>
             <a:fld id="{5BCAD085-E8A6-8845-BD4E-CB4CCA059FC4}" type="datetimeFigureOut">
               <a:rPr lang="en-US" smtClean="0"/>
-              <a:t>3/29/2026</a:t>
+              <a:t>4/4/2026</a:t>
             </a:fld>
             <a:endParaRPr lang="en-US"/>
           </a:p>
@@ -2297,7 +2320,7 @@
           <a:p>
             <a:fld id="{5BCAD085-E8A6-8845-BD4E-CB4CCA059FC4}" type="datetimeFigureOut">
               <a:rPr lang="en-US" smtClean="0"/>
-              <a:t>3/29/2026</a:t>
+              <a:t>4/4/2026</a:t>
             </a:fld>
             <a:endParaRPr lang="en-US"/>
           </a:p>
@@ -2549,7 +2572,7 @@
           <a:p>
             <a:fld id="{5BCAD085-E8A6-8845-BD4E-CB4CCA059FC4}" type="datetimeFigureOut">
               <a:rPr lang="en-US" smtClean="0"/>
-              <a:t>3/29/2026</a:t>
+              <a:t>4/4/2026</a:t>
             </a:fld>
             <a:endParaRPr lang="en-US"/>
           </a:p>
@@ -2760,7 +2783,7 @@
           <a:p>
             <a:fld id="{5BCAD085-E8A6-8845-BD4E-CB4CCA059FC4}" type="datetimeFigureOut">
               <a:rPr lang="en-US" smtClean="0"/>
-              <a:t>3/29/2026</a:t>
+              <a:t>4/4/2026</a:t>
             </a:fld>
             <a:endParaRPr lang="en-US"/>
           </a:p>
@@ -3172,7 +3195,114 @@
           <a:lstStyle/>
           <a:p>
             <a:r>
-              <a:t>TechSprint | Australia-focused SMB Growth</a:t>
+              <a:t>TechSprint | SMB Growth across Australia, Middle East &amp; India</a:t>
+            </a:r>
+          </a:p>
+        </p:txBody>
+      </p:sp>
+    </p:spTree>
+  </p:cSld>
+  <p:clrMapOvr>
+    <a:masterClrMapping/>
+  </p:clrMapOvr>
+</p:sld>
+</file>
+
+<file path=ppt/slides/slide10.xml><?xml version="1.0" encoding="utf-8"?>
+<p:sld xmlns:a="http://schemas.openxmlformats.org/drawingml/2006/main" xmlns:r="http://schemas.openxmlformats.org/officeDocument/2006/relationships" xmlns:p="http://schemas.openxmlformats.org/presentationml/2006/main">
+  <p:cSld>
+    <p:spTree>
+      <p:nvGrpSpPr>
+        <p:cNvPr id="1" name=""/>
+        <p:cNvGrpSpPr/>
+        <p:nvPr/>
+      </p:nvGrpSpPr>
+      <p:grpSpPr>
+        <a:xfrm>
+          <a:off x="0" y="0"/>
+          <a:ext cx="0" cy="0"/>
+          <a:chOff x="0" y="0"/>
+          <a:chExt cx="0" cy="0"/>
+        </a:xfrm>
+      </p:grpSpPr>
+      <p:sp>
+        <p:nvSpPr>
+          <p:cNvPr id="2" name="Title 1"/>
+          <p:cNvSpPr>
+            <a:spLocks noGrp="1"/>
+          </p:cNvSpPr>
+          <p:nvPr>
+            <p:ph type="title"/>
+          </p:nvPr>
+        </p:nvSpPr>
+        <p:spPr/>
+        <p:txBody>
+          <a:bodyPr/>
+          <a:lstStyle/>
+          <a:p>
+            <a:r>
+              <a:t>Conclusion</a:t>
+            </a:r>
+          </a:p>
+        </p:txBody>
+      </p:sp>
+      <p:sp>
+        <p:nvSpPr>
+          <p:cNvPr id="3" name="Content Placeholder 2"/>
+          <p:cNvSpPr>
+            <a:spLocks noGrp="1"/>
+          </p:cNvSpPr>
+          <p:nvPr>
+            <p:ph idx="1"/>
+          </p:nvPr>
+        </p:nvSpPr>
+        <p:spPr/>
+        <p:txBody>
+          <a:bodyPr wrap="square"/>
+          <a:lstStyle/>
+          <a:p>
+            <a:pPr lvl="0"/>
+            <a:r>
+              <a:rPr lang="en-US" sz="1800" dirty="0">
+                <a:latin typeface="Calibri"/>
+              </a:rPr>
+              <a:t>TechSprint is positioned as a practical growth partner for sole proprietors and SMBs across India, Australia, and the Middle East.</a:t>
+            </a:r>
+          </a:p>
+          <a:p>
+            <a:pPr lvl="0"/>
+            <a:r>
+              <a:rPr lang="en-US" sz="1800" dirty="0">
+                <a:latin typeface="Calibri"/>
+              </a:rPr>
+              <a:t>Services cover the full client lifecycle: digital launch, marketing, accounting, tax compliance, IT infrastructure, cloud engineering, SaaS tools, and data governance.</a:t>
+            </a:r>
+          </a:p>
+          <a:p>
+            <a:pPr lvl="0"/>
+            <a:r>
+              <a:rPr lang="en-US" sz="1800" dirty="0">
+                <a:latin typeface="Calibri"/>
+              </a:rPr>
+              <a:t>SaaS productization in Year 2 shifts TechSprint from labour-intensive delivery to scalable, high-margin recurring revenue.</a:t>
+            </a:r>
+          </a:p>
+          <a:p>
+            <a:pPr lvl="0"/>
+            <a:r>
+              <a:rPr lang="en-US" sz="1800" dirty="0">
+                <a:latin typeface="Calibri"/>
+              </a:rPr>
+              <a:t>Data governance commitment — multi-tenant isolation, regional data residency, and DPA compliance — builds the trust regulated-industry clients require from an offshore IT partner.</a:t>
+            </a:r>
+          </a:p>
+          <a:p>
+            <a:pPr lvl="0"/>
+            <a:r>
+              <a:rPr lang="en-US" sz="1800" dirty="0">
+                <a:latin typeface="Calibri"/>
+              </a:rPr>
+              <a:t>Targeting 10–15% of total revenue from SaaS products by Year 3, with data governance as a standard differentiator across all service lines.</a:t>
             </a:r>
           </a:p>
         </p:txBody>
@@ -3235,22 +3365,51 @@
         </p:nvSpPr>
         <p:spPr/>
         <p:txBody>
-          <a:bodyPr/>
-          <a:lstStyle/>
-          <a:p>
-            <a:pPr>
-              <a:defRPr sz="1800"/>
-            </a:pPr>
-            <a:r>
-              <a:t>Position TechSprint as a trusted partner for sole proprietors, small businesses, and medium organizations in Australia.</a:t>
-            </a:r>
-          </a:p>
-          <a:p>
-            <a:pPr>
-              <a:defRPr sz="1800"/>
-            </a:pPr>
-            <a:r>
-              <a:t>Support clients from digital presence and marketing to financial management and local tax compliance.</a:t>
+          <a:bodyPr wrap="square"/>
+          <a:lstStyle/>
+          <a:p>
+            <a:pPr lvl="0"/>
+            <a:r>
+              <a:rPr lang="en-US" sz="1800" dirty="0">
+                <a:latin typeface="Calibri"/>
+              </a:rPr>
+              <a:t>TechSprint is a trusted partner for sole proprietors, small businesses, and medium organizations across India, Australia, and the Middle East.</a:t>
+            </a:r>
+          </a:p>
+          <a:p>
+            <a:pPr lvl="0"/>
+            <a:r>
+              <a:rPr lang="en-US" sz="1800" dirty="0">
+                <a:latin typeface="Calibri"/>
+              </a:rPr>
+              <a:t>Seven core service lines: IT Maintenance &amp; Support, Application Change Management, FinOps Consulting, Cloud Engineering, Web Development, Accounting &amp; Bookkeeping, and E-commerce Platform Services.</a:t>
+            </a:r>
+          </a:p>
+          <a:p>
+            <a:pPr lvl="0"/>
+            <a:r>
+              <a:rPr lang="en-US" sz="1800" dirty="0">
+                <a:latin typeface="Calibri"/>
+              </a:rPr>
+              <a:t>SaaS products planned from Year 2: IT Ops Dashboard, FinOps Insights Tool, Bookkeeping Automation Suite, and E-commerce Health Monitor.</a:t>
+            </a:r>
+          </a:p>
+          <a:p>
+            <a:pPr lvl="0"/>
+            <a:r>
+              <a:rPr lang="en-US" sz="1800" dirty="0">
+                <a:latin typeface="Calibri"/>
+              </a:rPr>
+              <a:t>Enterprise-grade data governance is standard — multi-tenant isolation, data residency controls, and signed DPAs for every client.</a:t>
+            </a:r>
+          </a:p>
+          <a:p>
+            <a:pPr lvl="0"/>
+            <a:r>
+              <a:rPr lang="en-US" sz="1800" dirty="0">
+                <a:latin typeface="Calibri"/>
+              </a:rPr>
+              <a:t>Strategy covers the full client lifecycle: from digital launch to cloud optimization, SaaS adoption, and regulatory compliance.</a:t>
             </a:r>
           </a:p>
         </p:txBody>
@@ -3313,38 +3472,69 @@
         </p:nvSpPr>
         <p:spPr/>
         <p:txBody>
-          <a:bodyPr/>
-          <a:lstStyle/>
-          <a:p>
-            <a:pPr>
-              <a:defRPr sz="1800"/>
-            </a:pPr>
-            <a:r>
-              <a:t>Sole proprietorships launching or expanding digital presence.</a:t>
-            </a:r>
-          </a:p>
-          <a:p>
-            <a:pPr>
-              <a:defRPr sz="1800"/>
-            </a:pPr>
-            <a:r>
-              <a:t>Small businesses transitioning from manual systems to scalable applications.</a:t>
-            </a:r>
-          </a:p>
-          <a:p>
-            <a:pPr>
-              <a:defRPr sz="1800"/>
-            </a:pPr>
-            <a:r>
-              <a:t>Medium organizations requiring integrated accounting, inventory, and tax compliance tools.</a:t>
-            </a:r>
-          </a:p>
-          <a:p>
-            <a:pPr>
-              <a:defRPr sz="1800"/>
-            </a:pPr>
-            <a:r>
-              <a:t>Australian businesses needing local tax and regulatory support.</a:t>
+          <a:bodyPr wrap="square"/>
+          <a:lstStyle/>
+          <a:p>
+            <a:pPr lvl="0"/>
+            <a:r>
+              <a:rPr lang="en-US" sz="1800" dirty="0">
+                <a:latin typeface="Calibri"/>
+              </a:rPr>
+              <a:t>Sole proprietorships launching or expanding their digital presence and e-commerce storefronts.</a:t>
+            </a:r>
+          </a:p>
+          <a:p>
+            <a:pPr lvl="0"/>
+            <a:r>
+              <a:rPr lang="en-US" sz="1800" dirty="0">
+                <a:latin typeface="Calibri"/>
+              </a:rPr>
+              <a:t>Small businesses transitioning from manual systems to scalable applications and managed accounting.</a:t>
+            </a:r>
+          </a:p>
+          <a:p>
+            <a:pPr lvl="0"/>
+            <a:r>
+              <a:rPr lang="en-US" sz="1800" dirty="0">
+                <a:latin typeface="Calibri"/>
+              </a:rPr>
+              <a:t>Medium organizations requiring IT support, cloud optimization, application development, and regulatory compliance.</a:t>
+            </a:r>
+          </a:p>
+          <a:p>
+            <a:pPr lvl="0"/>
+            <a:r>
+              <a:rPr lang="en-US" sz="1800" dirty="0">
+                <a:latin typeface="Calibri"/>
+              </a:rPr>
+              <a:t>Australian businesses needing GST/BAS compliance, local payroll/tax support, and cloud governance.</a:t>
+            </a:r>
+          </a:p>
+          <a:p>
+            <a:pPr lvl="0"/>
+            <a:r>
+              <a:rPr lang="en-US" sz="1800" dirty="0">
+                <a:latin typeface="Calibri"/>
+              </a:rPr>
+              <a:t>SMBs in India, Australia, and the Middle East seeking an end-to-end managed services partner.</a:t>
+            </a:r>
+          </a:p>
+          <a:p>
+            <a:pPr lvl="0"/>
+            <a:r>
+              <a:rPr lang="en-US" sz="1800" dirty="0">
+                <a:latin typeface="Calibri"/>
+              </a:rPr>
+              <a:t>Businesses in regulated industries (finance, healthcare, retail) requiring data privacy compliance and auditability.</a:t>
+            </a:r>
+          </a:p>
+          <a:p>
+            <a:pPr lvl="0"/>
+            <a:r>
+              <a:rPr lang="en-US" sz="1800" dirty="0">
+                <a:latin typeface="Calibri"/>
+              </a:rPr>
+              <a:t>Companies seeking cost-effective, SLA-backed IT, FinOps, and e-commerce growth at 20–50% below local market rates.</a:t>
             </a:r>
           </a:p>
         </p:txBody>
@@ -3405,48 +3595,135 @@
             <p:ph idx="1"/>
           </p:nvPr>
         </p:nvSpPr>
-        <p:spPr/>
-        <p:txBody>
-          <a:bodyPr/>
-          <a:lstStyle/>
-          <a:p>
-            <a:pPr>
-              <a:defRPr sz="1800"/>
+        <p:spPr>
+          <a:xfrm>
+            <a:off x="627592" y="1625600"/>
+            <a:ext cx="8229600" cy="4525963"/>
+          </a:xfrm>
+        </p:spPr>
+        <p:txBody>
+          <a:bodyPr wrap="square">
+            <a:normAutofit fontScale="85000" lnSpcReduction="10000"/>
+          </a:bodyPr>
+          <a:lstStyle/>
+          <a:p>
+            <a:pPr lvl="0">
+              <a:buFont typeface="+mj-lt"/>
+              <a:buAutoNum type="arabicPeriod"/>
             </a:pPr>
             <a:r>
-              <a:t>Discovery &amp; Website Needs: establish credibility online with a professional website.</a:t>
-            </a:r>
-          </a:p>
-          <a:p>
-            <a:pPr>
-              <a:defRPr sz="1800"/>
+              <a:rPr lang="en-US" sz="1800" dirty="0">
+                <a:latin typeface="Calibri"/>
+              </a:rPr>
+              <a:t>Discovery &amp; Website Needs: establish credibility online with a professional website and digital presence.</a:t>
+            </a:r>
+          </a:p>
+          <a:p>
+            <a:pPr lvl="0">
+              <a:buFont typeface="+mj-lt"/>
+              <a:buAutoNum type="arabicPeriod"/>
             </a:pPr>
             <a:r>
-              <a:t>Digital Marketing &amp; Lead Generation: SEO, paid search, social media, content campaigns.</a:t>
-            </a:r>
-          </a:p>
-          <a:p>
-            <a:pPr>
-              <a:defRPr sz="1800"/>
+              <a:rPr lang="en-US" sz="1800" dirty="0">
+                <a:latin typeface="Calibri"/>
+              </a:rPr>
+              <a:t>Digital Marketing &amp; Lead Generation: SEO, paid search, social media, and content-driven campaigns.</a:t>
+            </a:r>
+          </a:p>
+          <a:p>
+            <a:pPr lvl="0">
+              <a:buFont typeface="+mj-lt"/>
+              <a:buAutoNum type="arabicPeriod"/>
             </a:pPr>
             <a:r>
-              <a:t>Operational Maturity: move from spreadsheets to stronger financial controls.</a:t>
-            </a:r>
-          </a:p>
-          <a:p>
-            <a:pPr>
-              <a:defRPr sz="1800"/>
+              <a:rPr lang="en-US" sz="1800" dirty="0">
+                <a:latin typeface="Calibri"/>
+              </a:rPr>
+              <a:t>Operational Maturity: move from spreadsheets to stronger financial controls and business systems.</a:t>
+            </a:r>
+          </a:p>
+          <a:p>
+            <a:pPr lvl="0">
+              <a:buFont typeface="+mj-lt"/>
+              <a:buAutoNum type="arabicPeriod"/>
             </a:pPr>
             <a:r>
-              <a:t>Software Adoption: adopt accounting and inventory applications like Zoho Books.</a:t>
-            </a:r>
-          </a:p>
-          <a:p>
-            <a:pPr>
-              <a:defRPr sz="1800"/>
+              <a:rPr lang="en-US" sz="1800" dirty="0">
+                <a:latin typeface="Calibri"/>
+              </a:rPr>
+              <a:t>Software Adoption: dedicated accounting, inventory, and workflow applications (QuickBooks, Xero, MYOB).</a:t>
+            </a:r>
+          </a:p>
+          <a:p>
+            <a:pPr lvl="0">
+              <a:buFont typeface="+mj-lt"/>
+              <a:buAutoNum type="arabicPeriod"/>
             </a:pPr>
             <a:r>
-              <a:t>Tax &amp; Compliance: focus on Australia-specific GST, BAS, and regulatory support.</a:t>
+              <a:rPr lang="en-US" sz="1800" dirty="0">
+                <a:latin typeface="Calibri"/>
+              </a:rPr>
+              <a:t>Tax &amp; Compliance: country-specific GST/BAS (Australia), VAT (UAE), and GST (India) support.</a:t>
+            </a:r>
+          </a:p>
+          <a:p>
+            <a:pPr lvl="0">
+              <a:buFont typeface="+mj-lt"/>
+              <a:buAutoNum type="arabicPeriod"/>
+            </a:pPr>
+            <a:r>
+              <a:rPr lang="en-US" sz="1800" dirty="0">
+                <a:latin typeface="Calibri"/>
+              </a:rPr>
+              <a:t>IT Infrastructure &amp; Support: 24/7 monitoring, helpdesk, system administration, and security operations.</a:t>
+            </a:r>
+          </a:p>
+          <a:p>
+            <a:pPr lvl="0">
+              <a:buFont typeface="+mj-lt"/>
+              <a:buAutoNum type="arabicPeriod"/>
+            </a:pPr>
+            <a:r>
+              <a:rPr lang="en-US" sz="1800" dirty="0">
+                <a:latin typeface="Calibri"/>
+              </a:rPr>
+              <a:t>Cloud &amp; FinOps Optimization: cloud migration, cost governance, DevOps, and ongoing FinOps advisory.</a:t>
+            </a:r>
+          </a:p>
+          <a:p>
+            <a:pPr lvl="0">
+              <a:buFont typeface="+mj-lt"/>
+              <a:buAutoNum type="arabicPeriod"/>
+            </a:pPr>
+            <a:r>
+              <a:rPr lang="en-US" sz="1800" dirty="0">
+                <a:latin typeface="Calibri"/>
+              </a:rPr>
+              <a:t>Advanced Application Development: custom web applications and application change management.</a:t>
+            </a:r>
+          </a:p>
+          <a:p>
+            <a:pPr lvl="0">
+              <a:buFont typeface="+mj-lt"/>
+              <a:buAutoNum type="arabicPeriod"/>
+            </a:pPr>
+            <a:r>
+              <a:rPr lang="en-US" sz="1800" dirty="0">
+                <a:latin typeface="Calibri"/>
+              </a:rPr>
+              <a:t>SaaS Adoption: migrate from bespoke services to subscription-based self-serve tools at a predictable monthly cost.</a:t>
+            </a:r>
+          </a:p>
+          <a:p>
+            <a:pPr lvl="0">
+              <a:buFont typeface="+mj-lt"/>
+              <a:buAutoNum type="arabicPeriod"/>
+            </a:pPr>
+            <a:r>
+              <a:rPr lang="en-US" sz="1800" dirty="0">
+                <a:latin typeface="Calibri"/>
+              </a:rPr>
+              <a:t>Data Trust &amp; Compliance: multi-tenant isolation, data residency, signed DPAs, and RBAC — standard for every client.</a:t>
             </a:r>
           </a:p>
         </p:txBody>
@@ -3509,38 +3786,69 @@
         </p:nvSpPr>
         <p:spPr/>
         <p:txBody>
-          <a:bodyPr/>
-          <a:lstStyle/>
-          <a:p>
-            <a:pPr>
-              <a:defRPr sz="1800"/>
-            </a:pPr>
-            <a:r>
-              <a:t>End-to-end solutions across digital, financial, and compliance needs.</a:t>
-            </a:r>
-          </a:p>
-          <a:p>
-            <a:pPr>
-              <a:defRPr sz="1800"/>
-            </a:pPr>
-            <a:r>
-              <a:t>From website development to digital marketing.</a:t>
-            </a:r>
-          </a:p>
-          <a:p>
-            <a:pPr>
-              <a:defRPr sz="1800"/>
-            </a:pPr>
-            <a:r>
-              <a:t>From basic bookkeeping to accounting and inventory automation.</a:t>
-            </a:r>
-          </a:p>
-          <a:p>
-            <a:pPr>
-              <a:defRPr sz="1800"/>
-            </a:pPr>
-            <a:r>
-              <a:t>From generic operations to Australia-specific tax compliance.</a:t>
+          <a:bodyPr wrap="square"/>
+          <a:lstStyle/>
+          <a:p>
+            <a:pPr lvl="0"/>
+            <a:r>
+              <a:rPr lang="en-US" sz="1800" dirty="0">
+                <a:latin typeface="Calibri"/>
+              </a:rPr>
+              <a:t>End-to-end solutions across digital, financial, cloud, and compliance needs.</a:t>
+            </a:r>
+          </a:p>
+          <a:p>
+            <a:pPr lvl="0"/>
+            <a:r>
+              <a:rPr lang="en-US" sz="1800" dirty="0">
+                <a:latin typeface="Calibri"/>
+              </a:rPr>
+              <a:t>From website development to digital marketing and brand growth.</a:t>
+            </a:r>
+          </a:p>
+          <a:p>
+            <a:pPr lvl="0"/>
+            <a:r>
+              <a:rPr lang="en-US" sz="1800" dirty="0">
+                <a:latin typeface="Calibri"/>
+              </a:rPr>
+              <a:t>From basic bookkeeping to accounting automation and inventory management.</a:t>
+            </a:r>
+          </a:p>
+          <a:p>
+            <a:pPr lvl="0"/>
+            <a:r>
+              <a:rPr lang="en-US" sz="1800" dirty="0">
+                <a:latin typeface="Calibri"/>
+              </a:rPr>
+              <a:t>From generic operations to country-specific tax compliance (Australia GST/BAS, UAE VAT, India GST).</a:t>
+            </a:r>
+          </a:p>
+          <a:p>
+            <a:pPr lvl="0"/>
+            <a:r>
+              <a:rPr lang="en-US" sz="1800" dirty="0">
+                <a:latin typeface="Calibri"/>
+              </a:rPr>
+              <a:t>From IT maintenance and support to cloud engineering and custom application development.</a:t>
+            </a:r>
+          </a:p>
+          <a:p>
+            <a:pPr lvl="0"/>
+            <a:r>
+              <a:rPr lang="en-US" sz="1800" dirty="0">
+                <a:latin typeface="Calibri"/>
+              </a:rPr>
+              <a:t>From bespoke service delivery to subscription-based SaaS products — IT monitoring, FinOps insights, bookkeeping automation, and e-commerce health tracking.</a:t>
+            </a:r>
+          </a:p>
+          <a:p>
+            <a:pPr lvl="0"/>
+            <a:r>
+              <a:rPr lang="en-US" sz="1800" dirty="0">
+                <a:latin typeface="Calibri"/>
+              </a:rPr>
+              <a:t>From basic data handling to enterprise-grade data governance — multi-tenant architectures, data residency, DPAs, and compliance with DPDP, Australia Privacy Act, and UAE PDPL.</a:t>
             </a:r>
           </a:p>
         </p:txBody>
@@ -3603,38 +3911,69 @@
         </p:nvSpPr>
         <p:spPr/>
         <p:txBody>
-          <a:bodyPr/>
-          <a:lstStyle/>
-          <a:p>
-            <a:pPr>
-              <a:defRPr sz="1800"/>
-            </a:pPr>
-            <a:r>
-              <a:t>Acquire sole proprietors and small businesses seeking digital presence.</a:t>
-            </a:r>
-          </a:p>
-          <a:p>
-            <a:pPr>
-              <a:defRPr sz="1800"/>
-            </a:pPr>
-            <a:r>
-              <a:t>Build awareness of operational efficiency solutions for growing organizations.</a:t>
-            </a:r>
-          </a:p>
-          <a:p>
-            <a:pPr>
-              <a:defRPr sz="1800"/>
-            </a:pPr>
-            <a:r>
-              <a:t>Highlight Australia-specific accounting and tax packages.</a:t>
-            </a:r>
-          </a:p>
-          <a:p>
-            <a:pPr>
-              <a:defRPr sz="1800"/>
-            </a:pPr>
-            <a:r>
-              <a:t>Demonstrate TechSprint’s ability to support business growth at every stage.</a:t>
+          <a:bodyPr wrap="square"/>
+          <a:lstStyle/>
+          <a:p>
+            <a:pPr lvl="0"/>
+            <a:r>
+              <a:rPr lang="en-US" sz="1800" dirty="0">
+                <a:latin typeface="Calibri"/>
+              </a:rPr>
+              <a:t>Acquire sole proprietors and small businesses seeking comprehensive IT, accounting, and e-commerce solutions.</a:t>
+            </a:r>
+          </a:p>
+          <a:p>
+            <a:pPr lvl="0"/>
+            <a:r>
+              <a:rPr lang="en-US" sz="1800" dirty="0">
+                <a:latin typeface="Calibri"/>
+              </a:rPr>
+              <a:t>Build awareness of operational efficiency solutions: IT maintenance, application changes, bookkeeping, and cloud FinOps.</a:t>
+            </a:r>
+          </a:p>
+          <a:p>
+            <a:pPr lvl="0"/>
+            <a:r>
+              <a:rPr lang="en-US" sz="1800" dirty="0">
+                <a:latin typeface="Calibri"/>
+              </a:rPr>
+              <a:t>Highlight Australia-specific accounting/tax packages (GST/BAS) and Middle East compliance requirements.</a:t>
+            </a:r>
+          </a:p>
+          <a:p>
+            <a:pPr lvl="0"/>
+            <a:r>
+              <a:rPr lang="en-US" sz="1800" dirty="0">
+                <a:latin typeface="Calibri"/>
+              </a:rPr>
+              <a:t>Promote e-commerce platform services across Shopify, WooCommerce, BigCommerce, and Magento.</a:t>
+            </a:r>
+          </a:p>
+          <a:p>
+            <a:pPr lvl="0"/>
+            <a:r>
+              <a:rPr lang="en-US" sz="1800" dirty="0">
+                <a:latin typeface="Calibri"/>
+              </a:rPr>
+              <a:t>Demonstrate ability to support business growth at every stage across all three geographies.</a:t>
+            </a:r>
+          </a:p>
+          <a:p>
+            <a:pPr lvl="0"/>
+            <a:r>
+              <a:rPr lang="en-US" sz="1800" dirty="0">
+                <a:latin typeface="Calibri"/>
+              </a:rPr>
+              <a:t>Build client confidence in data governance — position multi-tenancy, data residency, and DPAs as standard, not premium.</a:t>
+            </a:r>
+          </a:p>
+          <a:p>
+            <a:pPr lvl="0"/>
+            <a:r>
+              <a:rPr lang="en-US" sz="1800" dirty="0">
+                <a:latin typeface="Calibri"/>
+              </a:rPr>
+              <a:t>Position TechSprint as a SaaS provider in Year 2 — introduce subscription tools to existing clients and capture new inbound leads via product-led growth.</a:t>
             </a:r>
           </a:p>
         </p:txBody>
@@ -3697,38 +4036,78 @@
         </p:nvSpPr>
         <p:spPr/>
         <p:txBody>
-          <a:bodyPr/>
-          <a:lstStyle/>
-          <a:p>
-            <a:pPr>
-              <a:defRPr sz="1800"/>
-            </a:pPr>
-            <a:r>
+          <a:bodyPr wrap="square"/>
+          <a:lstStyle/>
+          <a:p>
+            <a:pPr lvl="0"/>
+            <a:r>
+              <a:rPr lang="en-US" sz="1800" dirty="0">
+                <a:latin typeface="Calibri"/>
+              </a:rPr>
               <a:t>"Launch your brand online with a polished website and digital marketing strategy."</a:t>
             </a:r>
           </a:p>
           <a:p>
-            <a:pPr>
-              <a:defRPr sz="1800"/>
-            </a:pPr>
-            <a:r>
+            <a:pPr lvl="0"/>
+            <a:r>
+              <a:rPr lang="en-US" sz="1800" dirty="0">
+                <a:latin typeface="Calibri"/>
+              </a:rPr>
               <a:t>"Move beyond spreadsheets with affordable accounting and inventory systems."</a:t>
             </a:r>
           </a:p>
           <a:p>
-            <a:pPr>
-              <a:defRPr sz="1800"/>
-            </a:pPr>
-            <a:r>
-              <a:t>"Stay compliant in Australia with GST and tax-ready financial tools."</a:t>
-            </a:r>
-          </a:p>
-          <a:p>
-            <a:pPr>
-              <a:defRPr sz="1800"/>
-            </a:pPr>
-            <a:r>
-              <a:t>"Scale from sole proprietorship to small business with one trusted partner."</a:t>
+            <a:pPr lvl="0"/>
+            <a:r>
+              <a:rPr lang="en-US" sz="1800" dirty="0">
+                <a:latin typeface="Calibri"/>
+              </a:rPr>
+              <a:t>"Stay compliant — Australia GST/BAS, UAE VAT, India GST — with one trusted partner."</a:t>
+            </a:r>
+          </a:p>
+          <a:p>
+            <a:pPr lvl="0"/>
+            <a:r>
+              <a:rPr lang="en-US" sz="1800" dirty="0">
+                <a:latin typeface="Calibri"/>
+              </a:rPr>
+              <a:t>"Scale from sole proprietorship to small business with enterprise-grade support at SMB prices."</a:t>
+            </a:r>
+          </a:p>
+          <a:p>
+            <a:pPr lvl="0"/>
+            <a:r>
+              <a:rPr lang="en-US" sz="1800" dirty="0">
+                <a:latin typeface="Calibri"/>
+              </a:rPr>
+              <a:t>"Secure your IT infrastructure with 24/7 monitoring, cloud optimization, and SLA-backed support."</a:t>
+            </a:r>
+          </a:p>
+          <a:p>
+            <a:pPr lvl="0"/>
+            <a:r>
+              <a:rPr lang="en-US" sz="1800" dirty="0">
+                <a:latin typeface="Calibri"/>
+              </a:rPr>
+              <a:t>"Launch and scale your online store on any platform — Shopify, WooCommerce, BigCommerce, Magento, or custom."</a:t>
+            </a:r>
+          </a:p>
+          <a:p>
+            <a:pPr lvl="0"/>
+            <a:r>
+              <a:rPr lang="en-US" sz="1800" dirty="0">
+                <a:latin typeface="Calibri"/>
+              </a:rPr>
+              <a:t>"Get SaaS-grade tools built by practitioners — IT monitoring, FinOps insights, bookkeeping automation, and e-commerce health by subscription."</a:t>
+            </a:r>
+          </a:p>
+          <a:p>
+            <a:pPr lvl="0"/>
+            <a:r>
+              <a:rPr lang="en-US" sz="1800" dirty="0">
+                <a:latin typeface="Calibri"/>
+              </a:rPr>
+              <a:t>"Your data stays yours — multi-tenant isolation, data residency controls, and signed DPAs. Compliant with DPDP, Australia Privacy Act, and UAE PDPL."</a:t>
             </a:r>
           </a:p>
         </p:txBody>
@@ -3791,66 +4170,69 @@
         </p:nvSpPr>
         <p:spPr/>
         <p:txBody>
-          <a:bodyPr/>
-          <a:lstStyle/>
-          <a:p>
-            <a:pPr>
-              <a:defRPr sz="1800"/>
-            </a:pPr>
-            <a:r>
-              <a:rPr dirty="0"/>
-              <a:t>Content marketing focused on business growth, digital transformation, and local compliance.</a:t>
-            </a:r>
-          </a:p>
-          <a:p>
-            <a:pPr>
-              <a:defRPr sz="1800"/>
-            </a:pPr>
-            <a:r>
-              <a:rPr dirty="0"/>
-              <a:t>Case studies and testimonials from small Australian businesses.</a:t>
-            </a:r>
-          </a:p>
-          <a:p>
-            <a:pPr>
-              <a:defRPr sz="1800"/>
-            </a:pPr>
-            <a:r>
-              <a:rPr dirty="0"/>
-              <a:t>Search campaigns targeting "small business website", "accounting software Australia", </a:t>
-            </a:r>
-            <a:r>
-              <a:rPr lang="en-IN" dirty="0"/>
-              <a:t> </a:t>
-            </a:r>
-            <a:r>
-              <a:rPr dirty="0"/>
-              <a:t>"Zoho Books implementation"</a:t>
-            </a:r>
-            <a:r>
-              <a:rPr lang="en-IN" dirty="0"/>
-              <a:t> and "</a:t>
-            </a:r>
-            <a:r>
-              <a:rPr lang="en-IN"/>
-              <a:t>Zoho Inventory </a:t>
-            </a:r>
-            <a:r>
-              <a:rPr lang="en-IN" dirty="0"/>
-              <a:t>implementation"</a:t>
-            </a:r>
-            <a:r>
-              <a:rPr dirty="0"/>
-              <a:t>.</a:t>
-            </a:r>
-          </a:p>
-          <a:p>
-            <a:pPr>
-              <a:defRPr sz="1800"/>
-            </a:pPr>
-            <a:r>
-              <a:rPr dirty="0"/>
-              <a:t>Social media campaigns highlighting digital marketing and finance transformation.</a:t>
+          <a:bodyPr wrap="square"/>
+          <a:lstStyle/>
+          <a:p>
+            <a:pPr lvl="0"/>
+            <a:r>
+              <a:rPr lang="en-US" sz="1800" dirty="0">
+                <a:latin typeface="Calibri"/>
+              </a:rPr>
+              <a:t>Content marketing: business growth, digital transformation, local compliance, and SaaS productivity tools.</a:t>
+            </a:r>
+          </a:p>
+          <a:p>
+            <a:pPr lvl="0"/>
+            <a:r>
+              <a:rPr lang="en-US" sz="1800" dirty="0">
+                <a:latin typeface="Calibri"/>
+              </a:rPr>
+              <a:t>Case studies and testimonials from Australian and Middle East SMBs — including SaaS adoption and data governance trust stories.</a:t>
+            </a:r>
+          </a:p>
+          <a:p>
+            <a:pPr lvl="0"/>
+            <a:r>
+              <a:rPr lang="en-US" sz="1800" dirty="0">
+                <a:latin typeface="Calibri"/>
+              </a:rPr>
+              <a:t>Search campaigns: 'small business website', 'accounting software Australia', 'IT support for small business', 'cloud cost management', 'SMB SaaS tools', 'data privacy compliance Australia'.</a:t>
+            </a:r>
+          </a:p>
+          <a:p>
+            <a:pPr lvl="0"/>
+            <a:r>
+              <a:rPr lang="en-US" sz="1800" dirty="0">
+                <a:latin typeface="Calibri"/>
+              </a:rPr>
+              <a:t>Social media: digital marketing, finance transformation, IT infrastructure, e-commerce launches, and subscription product announcements.</a:t>
+            </a:r>
+          </a:p>
+          <a:p>
+            <a:pPr lvl="0"/>
+            <a:r>
+              <a:rPr lang="en-US" sz="1800" dirty="0">
+                <a:latin typeface="Calibri"/>
+              </a:rPr>
+              <a:t>Product-led growth for SaaS products — free trials, usage-based onboarding, and in-product referrals to existing managed service clients.</a:t>
+            </a:r>
+          </a:p>
+          <a:p>
+            <a:pPr lvl="0"/>
+            <a:r>
+              <a:rPr lang="en-US" sz="1800" dirty="0">
+                <a:latin typeface="Calibri"/>
+              </a:rPr>
+              <a:t>Partner-led BD: three regional partners in India, Dubai, and Australia driving network-based outreach and referrals.</a:t>
+            </a:r>
+          </a:p>
+          <a:p>
+            <a:pPr lvl="0"/>
+            <a:r>
+              <a:rPr lang="en-US" sz="1800" dirty="0">
+                <a:latin typeface="Calibri"/>
+              </a:rPr>
+              <a:t>Regulatory compliance positioning: whitepaper and webinar series on DPDP Act (India), Privacy Act / APPs (Australia), and PDPL (UAE) as trust-building content.</a:t>
             </a:r>
           </a:p>
         </p:txBody>
@@ -3896,7 +4278,7 @@
           <a:lstStyle/>
           <a:p>
             <a:r>
-              <a:t>Conclusion</a:t>
+              <a:t>Data Governance &amp; Compliance</a:t>
             </a:r>
           </a:p>
         </p:txBody>
@@ -3913,30 +4295,78 @@
         </p:nvSpPr>
         <p:spPr/>
         <p:txBody>
-          <a:bodyPr/>
-          <a:lstStyle/>
-          <a:p>
-            <a:pPr>
-              <a:defRPr sz="1800"/>
-            </a:pPr>
-            <a:r>
-              <a:t>Position TechSprint as a practical growth partner for Australian sole proprietors and small businesses.</a:t>
-            </a:r>
-          </a:p>
-          <a:p>
-            <a:pPr>
-              <a:defRPr sz="1800"/>
-            </a:pPr>
-            <a:r>
-              <a:t>Align services with the customer lifecycle from website and marketing to accounting, inventory, and tax compliance.</a:t>
-            </a:r>
-          </a:p>
-          <a:p>
-            <a:pPr>
-              <a:defRPr sz="1800"/>
-            </a:pPr>
-            <a:r>
-              <a:t>Capture clients at each stage of business evolution.</a:t>
+          <a:bodyPr wrap="square"/>
+          <a:lstStyle/>
+          <a:p>
+            <a:pPr lvl="0"/>
+            <a:r>
+              <a:rPr lang="en-US" sz="1800" dirty="0">
+                <a:latin typeface="Calibri"/>
+              </a:rPr>
+              <a:t>Multi-tenancy by design: every client has logically isolated data — zero cross-tenant access possible.</a:t>
+            </a:r>
+          </a:p>
+          <a:p>
+            <a:pPr lvl="0"/>
+            <a:r>
+              <a:rPr lang="en-US" sz="1800" dirty="0">
+                <a:latin typeface="Calibri"/>
+              </a:rPr>
+              <a:t>Managed Services: dedicated VPN/bastion per client, no shared credentials or monitoring agents.</a:t>
+            </a:r>
+          </a:p>
+          <a:p>
+            <a:pPr lvl="0"/>
+            <a:r>
+              <a:rPr lang="en-US" sz="1800" dirty="0">
+                <a:latin typeface="Calibri"/>
+              </a:rPr>
+              <a:t>SaaS Products: tenant-scoped JWT at API gateway + RLS/schema-per-tenant at the data layer.</a:t>
+            </a:r>
+          </a:p>
+          <a:p>
+            <a:pPr lvl="0"/>
+            <a:r>
+              <a:rPr lang="en-US" sz="1800" dirty="0">
+                <a:latin typeface="Calibri"/>
+              </a:rPr>
+              <a:t>Accounting &amp; E-commerce: per-client isolated schemas / access tokens stored in encrypted secrets vault.</a:t>
+            </a:r>
+          </a:p>
+          <a:p>
+            <a:pPr lvl="0"/>
+            <a:r>
+              <a:rPr lang="en-US" sz="1800" dirty="0">
+                <a:latin typeface="Calibri"/>
+              </a:rPr>
+              <a:t>Data Residency: data stored in agreed region — India (DPDP Act 2023), Australia (Privacy Act 1988 / APPs), UAE (PDPL).</a:t>
+            </a:r>
+          </a:p>
+          <a:p>
+            <a:pPr lvl="0"/>
+            <a:r>
+              <a:rPr lang="en-US" sz="1800" dirty="0">
+                <a:latin typeface="Calibri"/>
+              </a:rPr>
+              <a:t>Data Processing Agreements (DPAs) signed with every client before data ingestion — standard, not optional.</a:t>
+            </a:r>
+          </a:p>
+          <a:p>
+            <a:pPr lvl="0"/>
+            <a:r>
+              <a:rPr lang="en-US" sz="1800" dirty="0">
+                <a:latin typeface="Calibri"/>
+              </a:rPr>
+              <a:t>RBAC enforced with quarterly access reviews; immutable audit logs retained for 12 months via SIEM.</a:t>
+            </a:r>
+          </a:p>
+          <a:p>
+            <a:pPr lvl="0"/>
+            <a:r>
+              <a:rPr lang="en-US" sz="1800" dirty="0">
+                <a:latin typeface="Calibri"/>
+              </a:rPr>
+              <a:t>Certifications roadmap: ISO 27001 within 18 months, SOC 2 Type II within 24 months.</a:t>
             </a:r>
           </a:p>
         </p:txBody>

</xml_diff>